<commit_message>
Rebuild procif_v4.pptx: manager/subordinate, generated figures, timing exercise
Regenerates the deck from tools/build_procif_slides.py with everything since
the last build: the bus roles renamed to manager and subordinate throughout
(with a note that AMBA called them master and slave until 2021, and that the
port names still do), the three AXI timing diagrams replaced by the ones
figs/make_figs.py generates, and a "Read the Timing Diagram" in-class slide
after the write-with-a-stall diagram, matching the new problem in procif.xml.

The write figures now show a write response that actually completes: BVALID
and BREADY overlap. The hand-drawn "Transaction 4 cycles" markers on those two
slides are gone, since they were positioned against the old images and the
corrected timing no longer matches them. Label boxes sized for "SLAVE" were
widened so "SUBORDINATE" fits on one line.

59 slides, validated against the original.

Co-Authored-By: Claude Opus 5 (1M context) <noreply@anthropic.com>
</commit_message>
<xml_diff>
--- a/units/unit04_procif/procif_v4.pptx
+++ b/units/unit04_procif/procif_v4.pptx
@@ -41,6 +41,7 @@
     <p:sldId id="296" r:id="rId22"/>
     <p:sldId id="292" r:id="rId23"/>
     <p:sldId id="300" r:id="rId24"/>
+    <p:sldId id="335" r:id="rId65"/>
     <p:sldId id="301" r:id="rId25"/>
     <p:sldId id="302" r:id="rId26"/>
     <p:sldId id="303" r:id="rId27"/>
@@ -11707,7 +11708,7 @@
                             <a:srgbClr val="262626"/>
                           </a:solidFill>
                         </a:rPr>
-                        <a:t>Identify bus master and slave</a:t>
+                        <a:t>Identify bus manager and subordinate</a:t>
                       </a:r>
                       <a:endParaRPr lang="en-US" sz="1500" dirty="0"/>
                     </a:p>
@@ -12242,7 +12243,7 @@
           <a:p>
             <a:r>
               <a:rPr lang="en-US" dirty="0"/>
-              <a:t>Master-Slave and Transactions</a:t>
+              <a:t>Managers and Subordinates</a:t>
             </a:r>
           </a:p>
         </p:txBody>
@@ -12751,7 +12752,7 @@
             </a:pPr>
             <a:r>
               <a:rPr lang="en-US" dirty="0"/>
-              <a:t>In AXI4-Lite:</a:t>
+              <a:t>Called master and slave until AMBA renamed them in 2021, and the port names (S_AXI, s_axilite) still do.   In AXI4-Lite:</a:t>
             </a:r>
           </a:p>
           <a:p>
@@ -12781,7 +12782,7 @@
                   </a:schemeClr>
                 </a:solidFill>
               </a:rPr>
-              <a:t>Master</a:t>
+              <a:t>Manager</a:t>
             </a:r>
             <a:r>
               <a:rPr lang="en-US" dirty="0"/>
@@ -12798,7 +12799,7 @@
                   </a:schemeClr>
                 </a:solidFill>
               </a:rPr>
-              <a:t>Slave</a:t>
+              <a:t>Subordinate</a:t>
             </a:r>
             <a:r>
               <a:rPr lang="en-US" dirty="0"/>
@@ -12843,7 +12844,7 @@
                   </a:schemeClr>
                 </a:solidFill>
               </a:rPr>
-              <a:t>MASTER</a:t>
+              <a:t>MANAGER</a:t>
             </a:r>
             <a:endParaRPr lang="en-US" dirty="0">
               <a:solidFill>
@@ -12869,8 +12870,8 @@
         </p:nvSpPr>
         <p:spPr>
           <a:xfrm>
-            <a:off x="7452443" y="1347798"/>
-            <a:ext cx="1490321" cy="400110"/>
+            <a:off x="7018103" y="1347798"/>
+            <a:ext cx="2359001" cy="400110"/>
           </a:xfrm>
           <a:prstGeom prst="rect">
             <a:avLst/>
@@ -12892,7 +12893,7 @@
                   </a:schemeClr>
                 </a:solidFill>
               </a:rPr>
-              <a:t>SLAVE</a:t>
+              <a:t>SUBORDINATE</a:t>
             </a:r>
             <a:endParaRPr lang="en-US" dirty="0">
               <a:solidFill>
@@ -13003,7 +13004,7 @@
                       <a:schemeClr val="accent6"/>
                     </a:solidFill>
                   </a:rPr>
-                  <a:t>master</a:t>
+                  <a:t>manager</a:t>
                 </a:r>
                 <a:r>
                   <a:rPr lang="en-US" dirty="0"/>
@@ -13095,7 +13096,7 @@
                       <a:srgbClr val="7030A0"/>
                     </a:solidFill>
                   </a:rPr>
-                  <a:t>slave</a:t>
+                  <a:t>subordinate</a:t>
                 </a:r>
                 <a:r>
                   <a:rPr lang="en-US" dirty="0"/>
@@ -13113,7 +13114,7 @@
                 <a:pPr lvl="1"/>
                 <a:r>
                   <a:rPr lang="en-US" dirty="0"/>
-                  <a:t>Slave can set these independently and any time it is ready</a:t>
+                  <a:t>Subordinate can set these independently and any time it is ready</a:t>
                 </a:r>
               </a:p>
               <a:p>
@@ -13174,14 +13175,14 @@
                 <a:pPr lvl="1"/>
                 <a:r>
                   <a:rPr lang="en-US" dirty="0"/>
-                  <a:t>After both transfers, the slave sets BVALID=1 with the write response</a:t>
+                  <a:t>After both transfers, the subordinate sets BVALID=1 with the write response</a:t>
                 </a:r>
               </a:p>
               <a:p>
                 <a:pPr lvl="1"/>
                 <a:r>
                   <a:rPr lang="en-US" dirty="0"/>
-                  <a:t>The master sets BREADY=1 to accept it; the response transfers when BVALID=BREADY=1</a:t>
+                  <a:t>The manager sets BREADY=1 to accept it; the response transfers when BVALID=BREADY=1</a:t>
                 </a:r>
               </a:p>
               <a:p>
@@ -13915,7 +13916,7 @@
                   </a:schemeClr>
                 </a:solidFill>
               </a:rPr>
-              <a:t>MASTER</a:t>
+              <a:t>MANAGER</a:t>
             </a:r>
             <a:endParaRPr lang="en-US" dirty="0">
               <a:solidFill>
@@ -13941,8 +13942,8 @@
         </p:nvSpPr>
         <p:spPr>
           <a:xfrm>
-            <a:off x="10609902" y="1499958"/>
-            <a:ext cx="1490321" cy="400110"/>
+            <a:off x="10175562" y="1499958"/>
+            <a:ext cx="2359001" cy="400110"/>
           </a:xfrm>
           <a:prstGeom prst="rect">
             <a:avLst/>
@@ -13964,7 +13965,7 @@
                   </a:schemeClr>
                 </a:solidFill>
               </a:rPr>
-              <a:t>SLAVE</a:t>
+              <a:t>SUBORDINATE</a:t>
             </a:r>
             <a:endParaRPr lang="en-US" dirty="0">
               <a:solidFill>
@@ -14030,7 +14031,7 @@
         <p:spPr>
           <a:xfrm>
             <a:off x="142559" y="1626723"/>
-            <a:ext cx="8057903" cy="3224738"/>
+            <a:ext cx="8057903" cy="3188379"/>
           </a:xfrm>
           <a:prstGeom prst="rect">
             <a:avLst/>
@@ -14094,125 +14095,6 @@
           </a:p>
         </p:txBody>
       </p:sp>
-      <p:cxnSp>
-        <p:nvCxnSpPr>
-          <p:cNvPr id="10" name="Straight Connector 9">
-            <a:extLst>
-              <a:ext uri="{FF2B5EF4-FFF2-40B4-BE49-F238E27FC236}">
-                <a16:creationId xmlns:a16="http://schemas.microsoft.com/office/drawing/2014/main" id="{EF19C5B9-EA49-E72C-5486-8BB3EC84730B}"/>
-              </a:ext>
-            </a:extLst>
-          </p:cNvPr>
-          <p:cNvCxnSpPr>
-            <a:cxnSpLocks/>
-          </p:cNvCxnSpPr>
-          <p:nvPr/>
-        </p:nvCxnSpPr>
-        <p:spPr>
-          <a:xfrm>
-            <a:off x="1818670" y="2321842"/>
-            <a:ext cx="0" cy="3276602"/>
-          </a:xfrm>
-          <a:prstGeom prst="line">
-            <a:avLst/>
-          </a:prstGeom>
-          <a:ln w="25400"/>
-        </p:spPr>
-        <p:style>
-          <a:lnRef idx="1">
-            <a:schemeClr val="accent1"/>
-          </a:lnRef>
-          <a:fillRef idx="0">
-            <a:schemeClr val="accent1"/>
-          </a:fillRef>
-          <a:effectRef idx="0">
-            <a:schemeClr val="accent1"/>
-          </a:effectRef>
-          <a:fontRef idx="minor">
-            <a:schemeClr val="tx1"/>
-          </a:fontRef>
-        </p:style>
-      </p:cxnSp>
-      <p:cxnSp>
-        <p:nvCxnSpPr>
-          <p:cNvPr id="11" name="Straight Connector 10">
-            <a:extLst>
-              <a:ext uri="{FF2B5EF4-FFF2-40B4-BE49-F238E27FC236}">
-                <a16:creationId xmlns:a16="http://schemas.microsoft.com/office/drawing/2014/main" id="{D706A970-5A1A-9EB6-66EF-04774D5681AE}"/>
-              </a:ext>
-            </a:extLst>
-          </p:cNvPr>
-          <p:cNvCxnSpPr/>
-          <p:nvPr/>
-        </p:nvCxnSpPr>
-        <p:spPr>
-          <a:xfrm>
-            <a:off x="5928287" y="2733770"/>
-            <a:ext cx="0" cy="2795587"/>
-          </a:xfrm>
-          <a:prstGeom prst="line">
-            <a:avLst/>
-          </a:prstGeom>
-          <a:ln w="25400"/>
-        </p:spPr>
-        <p:style>
-          <a:lnRef idx="1">
-            <a:schemeClr val="accent1"/>
-          </a:lnRef>
-          <a:fillRef idx="0">
-            <a:schemeClr val="accent1"/>
-          </a:fillRef>
-          <a:effectRef idx="0">
-            <a:schemeClr val="accent1"/>
-          </a:effectRef>
-          <a:fontRef idx="minor">
-            <a:schemeClr val="tx1"/>
-          </a:fontRef>
-        </p:style>
-      </p:cxnSp>
-      <p:sp>
-        <p:nvSpPr>
-          <p:cNvPr id="15" name="TextBox 14">
-            <a:extLst>
-              <a:ext uri="{FF2B5EF4-FFF2-40B4-BE49-F238E27FC236}">
-                <a16:creationId xmlns:a16="http://schemas.microsoft.com/office/drawing/2014/main" id="{64D5BC62-C73C-14D6-6B9F-7F7AD0CBAD22}"/>
-              </a:ext>
-            </a:extLst>
-          </p:cNvPr>
-          <p:cNvSpPr txBox="1"/>
-          <p:nvPr/>
-        </p:nvSpPr>
-        <p:spPr>
-          <a:xfrm>
-            <a:off x="3025074" y="4938423"/>
-            <a:ext cx="1262077" cy="646331"/>
-          </a:xfrm>
-          <a:prstGeom prst="rect">
-            <a:avLst/>
-          </a:prstGeom>
-          <a:noFill/>
-        </p:spPr>
-        <p:txBody>
-          <a:bodyPr wrap="none" rtlCol="0">
-            <a:spAutoFit/>
-          </a:bodyPr>
-          <a:lstStyle/>
-          <a:p>
-            <a:pPr algn="ctr"/>
-            <a:r>
-              <a:rPr lang="en-US" dirty="0"/>
-              <a:t>Transaction</a:t>
-            </a:r>
-            <a:br>
-              <a:rPr lang="en-US" dirty="0"/>
-            </a:br>
-            <a:r>
-              <a:rPr lang="en-US" dirty="0"/>
-              <a:t>4 cycles</a:t>
-            </a:r>
-          </a:p>
-        </p:txBody>
-      </p:sp>
       <p:sp>
         <p:nvSpPr>
           <p:cNvPr id="16" name="Content Placeholder 2">
@@ -14252,7 +14134,7 @@
           <a:p>
             <a:r>
               <a:rPr lang="en-US" dirty="0"/>
-              <a:t>Slave is ready before master </a:t>
+              <a:t>Subordinate is ready before manager </a:t>
             </a:r>
           </a:p>
           <a:p>
@@ -14332,7 +14214,7 @@
         <p:spPr>
           <a:xfrm>
             <a:off x="197263" y="1859756"/>
-            <a:ext cx="7842381" cy="3138487"/>
+            <a:ext cx="7842381" cy="3124077"/>
           </a:xfrm>
           <a:prstGeom prst="rect">
             <a:avLst/>
@@ -14396,125 +14278,6 @@
           </a:p>
         </p:txBody>
       </p:sp>
-      <p:cxnSp>
-        <p:nvCxnSpPr>
-          <p:cNvPr id="10" name="Straight Connector 9">
-            <a:extLst>
-              <a:ext uri="{FF2B5EF4-FFF2-40B4-BE49-F238E27FC236}">
-                <a16:creationId xmlns:a16="http://schemas.microsoft.com/office/drawing/2014/main" id="{542305EF-3619-44A8-63CC-D35E7453D130}"/>
-              </a:ext>
-            </a:extLst>
-          </p:cNvPr>
-          <p:cNvCxnSpPr>
-            <a:cxnSpLocks/>
-          </p:cNvCxnSpPr>
-          <p:nvPr/>
-        </p:nvCxnSpPr>
-        <p:spPr>
-          <a:xfrm>
-            <a:off x="1832958" y="2381662"/>
-            <a:ext cx="0" cy="3276602"/>
-          </a:xfrm>
-          <a:prstGeom prst="line">
-            <a:avLst/>
-          </a:prstGeom>
-          <a:ln w="25400"/>
-        </p:spPr>
-        <p:style>
-          <a:lnRef idx="1">
-            <a:schemeClr val="accent1"/>
-          </a:lnRef>
-          <a:fillRef idx="0">
-            <a:schemeClr val="accent1"/>
-          </a:fillRef>
-          <a:effectRef idx="0">
-            <a:schemeClr val="accent1"/>
-          </a:effectRef>
-          <a:fontRef idx="minor">
-            <a:schemeClr val="tx1"/>
-          </a:fontRef>
-        </p:style>
-      </p:cxnSp>
-      <p:cxnSp>
-        <p:nvCxnSpPr>
-          <p:cNvPr id="11" name="Straight Connector 10">
-            <a:extLst>
-              <a:ext uri="{FF2B5EF4-FFF2-40B4-BE49-F238E27FC236}">
-                <a16:creationId xmlns:a16="http://schemas.microsoft.com/office/drawing/2014/main" id="{86A0E8C4-F7DE-76DD-E627-595B6FDCE964}"/>
-              </a:ext>
-            </a:extLst>
-          </p:cNvPr>
-          <p:cNvCxnSpPr/>
-          <p:nvPr/>
-        </p:nvCxnSpPr>
-        <p:spPr>
-          <a:xfrm>
-            <a:off x="5023413" y="2797378"/>
-            <a:ext cx="0" cy="2795587"/>
-          </a:xfrm>
-          <a:prstGeom prst="line">
-            <a:avLst/>
-          </a:prstGeom>
-          <a:ln w="25400"/>
-        </p:spPr>
-        <p:style>
-          <a:lnRef idx="1">
-            <a:schemeClr val="accent1"/>
-          </a:lnRef>
-          <a:fillRef idx="0">
-            <a:schemeClr val="accent1"/>
-          </a:fillRef>
-          <a:effectRef idx="0">
-            <a:schemeClr val="accent1"/>
-          </a:effectRef>
-          <a:fontRef idx="minor">
-            <a:schemeClr val="tx1"/>
-          </a:fontRef>
-        </p:style>
-      </p:cxnSp>
-      <p:sp>
-        <p:nvSpPr>
-          <p:cNvPr id="15" name="TextBox 14">
-            <a:extLst>
-              <a:ext uri="{FF2B5EF4-FFF2-40B4-BE49-F238E27FC236}">
-                <a16:creationId xmlns:a16="http://schemas.microsoft.com/office/drawing/2014/main" id="{0EBD7E54-EC2C-2AD4-3D3B-E4718376672E}"/>
-              </a:ext>
-            </a:extLst>
-          </p:cNvPr>
-          <p:cNvSpPr txBox="1"/>
-          <p:nvPr/>
-        </p:nvSpPr>
-        <p:spPr>
-          <a:xfrm>
-            <a:off x="3039362" y="4998243"/>
-            <a:ext cx="1262077" cy="646331"/>
-          </a:xfrm>
-          <a:prstGeom prst="rect">
-            <a:avLst/>
-          </a:prstGeom>
-          <a:noFill/>
-        </p:spPr>
-        <p:txBody>
-          <a:bodyPr wrap="none" rtlCol="0">
-            <a:spAutoFit/>
-          </a:bodyPr>
-          <a:lstStyle/>
-          <a:p>
-            <a:pPr algn="ctr"/>
-            <a:r>
-              <a:rPr lang="en-US" dirty="0"/>
-              <a:t>Transaction</a:t>
-            </a:r>
-            <a:br>
-              <a:rPr lang="en-US" dirty="0"/>
-            </a:br>
-            <a:r>
-              <a:rPr lang="en-US" dirty="0"/>
-              <a:t>4 cycles</a:t>
-            </a:r>
-          </a:p>
-        </p:txBody>
-      </p:sp>
       <p:sp>
         <p:nvSpPr>
           <p:cNvPr id="16" name="Content Placeholder 2">
@@ -14554,13 +14317,13 @@
           <a:p>
             <a:r>
               <a:rPr lang="en-US" dirty="0"/>
-              <a:t>Master sets valid </a:t>
+              <a:t>Manager sets valid </a:t>
             </a:r>
           </a:p>
           <a:p>
             <a:r>
               <a:rPr lang="en-US" dirty="0"/>
-              <a:t>Slave is not ready</a:t>
+              <a:t>Subordinate is not ready</a:t>
             </a:r>
           </a:p>
           <a:p>
@@ -14701,7 +14464,7 @@
                 <a:pPr lvl="1"/>
                 <a:r>
                   <a:rPr lang="en-US" dirty="0"/>
-                  <a:t>Master sets AWVALID=1, AWADDR=</a:t>
+                  <a:t>Manager sets AWVALID=1, AWADDR=</a:t>
                 </a:r>
                 <a14:m>
                   <m:oMath xmlns:m="http://schemas.openxmlformats.org/officeDocument/2006/math">
@@ -14736,14 +14499,14 @@
                 <a:pPr lvl="1"/>
                 <a:r>
                   <a:rPr lang="en-US" dirty="0"/>
-                  <a:t>Slave is ready: AWREADY=WREADY=1</a:t>
+                  <a:t>Subordinate is ready: AWREADY=WREADY=1</a:t>
                 </a:r>
               </a:p>
               <a:p>
                 <a:pPr lvl="1"/>
                 <a:r>
                   <a:rPr lang="en-US" dirty="0"/>
-                  <a:t>Both address and data are transferred to slave</a:t>
+                  <a:t>Both address and data are transferred to subordinate</a:t>
                 </a:r>
               </a:p>
               <a:p>
@@ -14756,14 +14519,14 @@
                 <a:pPr lvl="1"/>
                 <a:r>
                   <a:rPr lang="en-US" dirty="0"/>
-                  <a:t>Slave set BVALID=1 signaling transaction complete on slave side</a:t>
+                  <a:t>Subordinate set BVALID=1 signaling transaction complete on subordinate side</a:t>
                 </a:r>
               </a:p>
               <a:p>
                 <a:pPr lvl="1"/>
                 <a:r>
                   <a:rPr lang="en-US" dirty="0"/>
-                  <a:t>Slave registers </a:t>
+                  <a:t>Subordinate registers </a:t>
                 </a:r>
               </a:p>
               <a:p>
@@ -14776,14 +14539,14 @@
                 <a:pPr lvl="1"/>
                 <a:r>
                   <a:rPr lang="en-US" dirty="0"/>
-                  <a:t>Master acknowledges with BREADY=1</a:t>
+                  <a:t>Manager acknowledges with BREADY=1</a:t>
                 </a:r>
               </a:p>
               <a:p>
                 <a:pPr lvl="1"/>
                 <a:r>
                   <a:rPr lang="en-US" dirty="0"/>
-                  <a:t>Master starts next transaction in same clock cycle</a:t>
+                  <a:t>Manager starts next transaction in same clock cycle</a:t>
                 </a:r>
               </a:p>
               <a:p>
@@ -14811,7 +14574,7 @@
                 </a:r>
                 <a:r>
                   <a:rPr lang="en-US" dirty="0"/>
-                  <a:t>= 2 clock cycles (master write + slave register)</a:t>
+                  <a:t>= 2 clock cycles (manager write + subordinate register)</a:t>
                 </a:r>
               </a:p>
               <a:p>
@@ -14978,14 +14741,14 @@
             <a:pPr lvl="1"/>
             <a:r>
               <a:rPr lang="en-US" dirty="0"/>
-              <a:t>Master sets data and address on cycle 0</a:t>
+              <a:t>Manager sets data and address on cycle 0</a:t>
             </a:r>
           </a:p>
           <a:p>
             <a:pPr lvl="1"/>
             <a:r>
               <a:rPr lang="en-US" dirty="0"/>
-              <a:t>Slave is ready</a:t>
+              <a:t>Subordinate is ready</a:t>
             </a:r>
           </a:p>
           <a:p>
@@ -14998,13 +14761,13 @@
             <a:pPr lvl="1"/>
             <a:r>
               <a:rPr lang="en-US" dirty="0"/>
-              <a:t>Slave takes 1-2 additional clock cycles for BREADY=1</a:t>
+              <a:t>Subordinate takes 1-2 additional clock cycles for BREADY=1</a:t>
             </a:r>
           </a:p>
           <a:p>
             <a:r>
               <a:rPr lang="en-US" dirty="0"/>
-              <a:t>Master takes at 1-2 additional clock cycles for BVALID=1 and next input</a:t>
+              <a:t>Manager takes at 1-2 additional clock cycles for BVALID=1 and next input</a:t>
             </a:r>
           </a:p>
         </p:txBody>
@@ -15209,7 +14972,7 @@
                       <a:schemeClr val="accent6"/>
                     </a:solidFill>
                   </a:rPr>
-                  <a:t>master</a:t>
+                  <a:t>manager</a:t>
                 </a:r>
                 <a:r>
                   <a:rPr lang="en-US" dirty="0"/>
@@ -15266,7 +15029,7 @@
                       <a:srgbClr val="7030A0"/>
                     </a:solidFill>
                   </a:rPr>
-                  <a:t>slave</a:t>
+                  <a:t>subordinate</a:t>
                 </a:r>
                 <a:r>
                   <a:rPr lang="en-US" dirty="0"/>
@@ -15283,7 +15046,7 @@
               <a:p>
                 <a:r>
                   <a:rPr lang="en-US" dirty="0"/>
-                  <a:t>When slave has fetched data:</a:t>
+                  <a:t>When subordinate has fetched data:</a:t>
                 </a:r>
               </a:p>
               <a:p>
@@ -15321,7 +15084,7 @@
                 <a:pPr lvl="1"/>
                 <a:r>
                   <a:rPr lang="en-US" dirty="0"/>
-                  <a:t>Master asserts RREADY=1 when ready to accept data</a:t>
+                  <a:t>Manager asserts RREADY=1 when ready to accept data</a:t>
                 </a:r>
               </a:p>
               <a:p>
@@ -15894,7 +15657,7 @@
                   </a:schemeClr>
                 </a:solidFill>
               </a:rPr>
-              <a:t>MASTER</a:t>
+              <a:t>MANAGER</a:t>
             </a:r>
             <a:endParaRPr lang="en-US" dirty="0">
               <a:solidFill>
@@ -15920,8 +15683,8 @@
         </p:nvSpPr>
         <p:spPr>
           <a:xfrm>
-            <a:off x="10609902" y="1499958"/>
-            <a:ext cx="1490321" cy="400110"/>
+            <a:off x="10175562" y="1499958"/>
+            <a:ext cx="2359001" cy="400110"/>
           </a:xfrm>
           <a:prstGeom prst="rect">
             <a:avLst/>
@@ -15943,7 +15706,7 @@
                   </a:schemeClr>
                 </a:solidFill>
               </a:rPr>
-              <a:t>SLAVE</a:t>
+              <a:t>SUBORDINATE</a:t>
             </a:r>
             <a:endParaRPr lang="en-US" dirty="0">
               <a:solidFill>
@@ -16134,7 +15897,7 @@
           <a:p>
             <a:r>
               <a:rPr lang="en-US" dirty="0"/>
-              <a:t>Slave is initially ready</a:t>
+              <a:t>Subordinate is initially ready</a:t>
             </a:r>
             <a:br>
               <a:rPr lang="en-US" dirty="0"/>
@@ -16147,7 +15910,7 @@
           <a:p>
             <a:r>
               <a:rPr lang="en-US" dirty="0"/>
-              <a:t>Slave immediately accepts </a:t>
+              <a:t>Subordinate immediately accepts </a:t>
             </a:r>
             <a:br>
               <a:rPr lang="en-US" dirty="0"/>
@@ -16160,7 +15923,7 @@
           <a:p>
             <a:r>
               <a:rPr lang="en-US" dirty="0"/>
-              <a:t>Master is immediately available for </a:t>
+              <a:t>Manager is immediately available for </a:t>
             </a:r>
           </a:p>
           <a:p>
@@ -16223,7 +15986,7 @@
         <p:spPr>
           <a:xfrm>
             <a:off x="646847" y="2245057"/>
-            <a:ext cx="7795784" cy="2901570"/>
+            <a:ext cx="7795784" cy="2514159"/>
           </a:xfrm>
           <a:prstGeom prst="rect">
             <a:avLst/>
@@ -16330,7 +16093,7 @@
                 <a:pPr lvl="1"/>
                 <a:r>
                   <a:rPr lang="en-US" dirty="0"/>
-                  <a:t>Master sets ARADDR=</a:t>
+                  <a:t>Manager sets ARADDR=</a:t>
                 </a:r>
                 <a14:m>
                   <m:oMath xmlns:m="http://schemas.openxmlformats.org/officeDocument/2006/math">
@@ -16351,14 +16114,14 @@
                 <a:pPr lvl="1"/>
                 <a:r>
                   <a:rPr lang="en-US" dirty="0"/>
-                  <a:t>Slave is ready: ARREADY=1</a:t>
+                  <a:t>Subordinate is ready: ARREADY=1</a:t>
                 </a:r>
               </a:p>
               <a:p>
                 <a:pPr lvl="1"/>
                 <a:r>
                   <a:rPr lang="en-US" dirty="0"/>
-                  <a:t>Address is transferred to slave</a:t>
+                  <a:t>Address is transferred to subordinate</a:t>
                 </a:r>
               </a:p>
               <a:p>
@@ -16371,7 +16134,7 @@
                 <a:pPr lvl="1"/>
                 <a:r>
                   <a:rPr lang="en-US" dirty="0"/>
-                  <a:t>Slave set RVALID=1 with data RDATA=</a:t>
+                  <a:t>Subordinate set RVALID=1 with data RDATA=</a:t>
                 </a:r>
                 <a14:m>
                   <m:oMath xmlns:m="http://schemas.openxmlformats.org/officeDocument/2006/math">
@@ -16389,7 +16152,7 @@
                 <a:pPr lvl="1"/>
                 <a:r>
                   <a:rPr lang="en-US" dirty="0"/>
-                  <a:t>Master is immediately ready, RREADY=1</a:t>
+                  <a:t>Manager is immediately ready, RREADY=1</a:t>
                 </a:r>
               </a:p>
               <a:p>
@@ -16402,7 +16165,7 @@
                 <a:pPr lvl="1"/>
                 <a:r>
                   <a:rPr lang="en-US" dirty="0"/>
-                  <a:t>Master moves to next read address</a:t>
+                  <a:t>Manager moves to next read address</a:t>
                 </a:r>
               </a:p>
               <a:p>
@@ -24486,7 +24249,7 @@
             </a:r>
             <a:r>
               <a:rPr lang="en-US" dirty="0"/>
-              <a:t> (AXI4-Lite slave)</a:t>
+              <a:t> (AXI4-Lite subordinate)</a:t>
             </a:r>
           </a:p>
           <a:p>
@@ -40433,6 +40196,379 @@
                 </a:solidFill>
               </a:rPr>
               <a:t>Also in the LLM grader: Unit 4 › Storage partitioning</a:t>
+            </a:r>
+            <a:endParaRPr lang="en-US" sz="1200" dirty="0"/>
+          </a:p>
+        </p:txBody>
+      </p:sp>
+      <p:sp>
+        <p:nvSpPr>
+          <p:cNvPr id="8" name="Slide Number Placeholder 8"/>
+          <p:cNvSpPr>
+            <a:spLocks noGrp="1"/>
+          </p:cNvSpPr>
+          <p:nvPr>
+            <p:ph type="sldNum" sz="quarter" idx="12"/>
+          </p:nvPr>
+        </p:nvSpPr>
+        <p:spPr/>
+        <p:txBody>
+          <a:bodyPr/>
+          <a:lstStyle/>
+          <a:p>
+            <a:fld id="{629637A9-119A-49DA-BD12-AAC58B377D80}" type="slidenum">
+              <a:rPr lang="en-US" smtClean="0"/>
+              <a:t>‹#›</a:t>
+            </a:fld>
+            <a:endParaRPr lang="en-US" dirty="0"/>
+          </a:p>
+        </p:txBody>
+      </p:sp>
+    </p:spTree>
+  </p:cSld>
+  <p:clrMapOvr>
+    <a:masterClrMapping/>
+  </p:clrMapOvr>
+</p:sld>
+</file>
+
+<file path=ppt/slides/slide59.xml><?xml version="1.0" encoding="utf-8"?>
+<p:sld xmlns:a="http://schemas.openxmlformats.org/drawingml/2006/main" xmlns:r="http://schemas.openxmlformats.org/officeDocument/2006/relationships" xmlns:p="http://schemas.openxmlformats.org/presentationml/2006/main">
+  <p:cSld>
+    <p:spTree>
+      <p:nvGrpSpPr>
+        <p:cNvPr id="1" name=""/>
+        <p:cNvGrpSpPr/>
+        <p:nvPr/>
+      </p:nvGrpSpPr>
+      <p:grpSpPr>
+        <a:xfrm>
+          <a:off x="0" y="0"/>
+          <a:ext cx="0" cy="0"/>
+          <a:chOff x="0" y="0"/>
+          <a:chExt cx="0" cy="0"/>
+        </a:xfrm>
+      </p:grpSpPr>
+      <p:sp>
+        <p:nvSpPr>
+          <p:cNvPr id="2" name="Title 2"/>
+          <p:cNvSpPr>
+            <a:spLocks noGrp="1"/>
+          </p:cNvSpPr>
+          <p:nvPr>
+            <p:ph type="title"/>
+          </p:nvPr>
+        </p:nvSpPr>
+        <p:spPr/>
+        <p:txBody>
+          <a:bodyPr/>
+          <a:lstStyle/>
+          <a:p>
+            <a:r>
+              <a:rPr lang="en-US" dirty="0"/>
+              <a:t>Read the Timing Diagram</a:t>
+            </a:r>
+          </a:p>
+        </p:txBody>
+      </p:sp>
+      <p:sp>
+        <p:nvSpPr>
+          <p:cNvPr id="3" name="Shape 3"/>
+          <p:cNvSpPr/>
+          <p:nvPr/>
+        </p:nvSpPr>
+        <p:spPr>
+          <a:xfrm>
+            <a:off x="9646920" y="621792"/>
+            <a:ext cx="1463040" cy="384048"/>
+          </a:xfrm>
+          <a:prstGeom prst="roundRect">
+            <a:avLst>
+              <a:gd name="adj" fmla="val 50000"/>
+            </a:avLst>
+          </a:prstGeom>
+          <a:solidFill>
+            <a:srgbClr val="57068C"/>
+          </a:solidFill>
+          <a:ln>
+            <a:noFill/>
+          </a:ln>
+        </p:spPr>
+        <p:txBody>
+          <a:bodyPr wrap="square" lIns="54864" tIns="27432" rIns="54864" bIns="27432" anchor="ctr" rtlCol="0">
+            <a:noAutofit/>
+          </a:bodyPr>
+          <a:lstStyle/>
+          <a:p>
+            <a:pPr algn="ctr"/>
+            <a:r>
+              <a:rPr lang="en-US" sz="1300" b="1" dirty="0">
+                <a:solidFill>
+                  <a:srgbClr val="FFFFFF"/>
+                </a:solidFill>
+              </a:rPr>
+              <a:t>IN CLASS</a:t>
+            </a:r>
+            <a:endParaRPr lang="en-US" sz="1300" dirty="0"/>
+          </a:p>
+        </p:txBody>
+      </p:sp>
+      <p:sp>
+        <p:nvSpPr>
+          <p:cNvPr id="4" name="TextBox 4"/>
+          <p:cNvSpPr txBox="1"/>
+          <p:nvPr/>
+        </p:nvSpPr>
+        <p:spPr>
+          <a:xfrm>
+            <a:off x="1097280" y="1645920"/>
+            <a:ext cx="10058400" cy="365760"/>
+          </a:xfrm>
+          <a:prstGeom prst="rect">
+            <a:avLst/>
+          </a:prstGeom>
+          <a:noFill/>
+        </p:spPr>
+        <p:txBody>
+          <a:bodyPr wrap="square" lIns="0" tIns="0" rIns="0" bIns="0" anchor="t" rtlCol="0">
+            <a:noAutofit/>
+          </a:bodyPr>
+          <a:lstStyle/>
+          <a:p>
+            <a:r>
+              <a:rPr lang="en-US" sz="1800" dirty="0">
+                <a:solidFill>
+                  <a:srgbClr val="262626"/>
+                </a:solidFill>
+              </a:rPr>
+              <a:t>Using the write-with-a-stall diagram on the previous slide:</a:t>
+            </a:r>
+            <a:endParaRPr lang="en-US" sz="1800" dirty="0"/>
+          </a:p>
+        </p:txBody>
+      </p:sp>
+      <p:sp>
+        <p:nvSpPr>
+          <p:cNvPr id="5" name="TextBox 5"/>
+          <p:cNvSpPr txBox="1"/>
+          <p:nvPr/>
+        </p:nvSpPr>
+        <p:spPr>
+          <a:xfrm>
+            <a:off x="1097280" y="2240280"/>
+            <a:ext cx="9692640" cy="3108960"/>
+          </a:xfrm>
+          <a:prstGeom prst="rect">
+            <a:avLst/>
+          </a:prstGeom>
+          <a:noFill/>
+        </p:spPr>
+        <p:txBody>
+          <a:bodyPr wrap="square" lIns="0" tIns="0" rIns="0" bIns="0" anchor="t" rtlCol="0">
+            <a:noAutofit/>
+          </a:bodyPr>
+          <a:lstStyle/>
+          <a:p>
+            <a:pPr marL="411480" indent="-411480">
+              <a:spcBef>
+                <a:spcPts val="900"/>
+              </a:spcBef>
+            </a:pPr>
+            <a:r>
+              <a:rPr lang="en-US" sz="1800" b="1" dirty="0">
+                <a:solidFill>
+                  <a:srgbClr val="57068C"/>
+                </a:solidFill>
+              </a:rPr>
+              <a:t>(a)</a:t>
+            </a:r>
+            <a:r>
+              <a:rPr lang="en-US" sz="1800" dirty="0">
+                <a:solidFill>
+                  <a:srgbClr val="262626"/>
+                </a:solidFill>
+              </a:rPr>
+              <a:t xml:space="preserve">	In which cycle does the address transfer on the AW channel? How do you know?</a:t>
+            </a:r>
+            <a:endParaRPr lang="en-US" sz="1800" dirty="0"/>
+          </a:p>
+          <a:p>
+            <a:pPr marL="411480" indent="-411480">
+              <a:spcBef>
+                <a:spcPts val="900"/>
+              </a:spcBef>
+            </a:pPr>
+            <a:r>
+              <a:rPr lang="en-US" sz="1800" b="1" dirty="0">
+                <a:solidFill>
+                  <a:srgbClr val="57068C"/>
+                </a:solidFill>
+              </a:rPr>
+              <a:t>(b)</a:t>
+            </a:r>
+            <a:r>
+              <a:rPr lang="en-US" sz="1800" dirty="0">
+                <a:solidFill>
+                  <a:srgbClr val="262626"/>
+                </a:solidFill>
+              </a:rPr>
+              <a:t xml:space="preserve">	In which cycle does the write data transfer on the W channel?</a:t>
+            </a:r>
+            <a:endParaRPr lang="en-US" sz="1800" dirty="0"/>
+          </a:p>
+          <a:p>
+            <a:pPr marL="411480" indent="-411480">
+              <a:spcBef>
+                <a:spcPts val="900"/>
+              </a:spcBef>
+            </a:pPr>
+            <a:r>
+              <a:rPr lang="en-US" sz="1800" b="1" dirty="0">
+                <a:solidFill>
+                  <a:srgbClr val="57068C"/>
+                </a:solidFill>
+              </a:rPr>
+              <a:t>(c)</a:t>
+            </a:r>
+            <a:r>
+              <a:rPr lang="en-US" sz="1800" dirty="0">
+                <a:solidFill>
+                  <a:srgbClr val="262626"/>
+                </a:solidFill>
+              </a:rPr>
+              <a:t xml:space="preserve">	In which cycle does the write response transfer on the B channel?</a:t>
+            </a:r>
+            <a:endParaRPr lang="en-US" sz="1800" dirty="0"/>
+          </a:p>
+          <a:p>
+            <a:pPr marL="411480" indent="-411480">
+              <a:spcBef>
+                <a:spcPts val="900"/>
+              </a:spcBef>
+            </a:pPr>
+            <a:r>
+              <a:rPr lang="en-US" sz="1800" b="1" dirty="0">
+                <a:solidFill>
+                  <a:srgbClr val="57068C"/>
+                </a:solidFill>
+              </a:rPr>
+              <a:t>(d)</a:t>
+            </a:r>
+            <a:r>
+              <a:rPr lang="en-US" sz="1800" dirty="0">
+                <a:solidFill>
+                  <a:srgbClr val="262626"/>
+                </a:solidFill>
+              </a:rPr>
+              <a:t xml:space="preserve">	The hatched region marks a wait. Which side is waiting, what is it waiting for, and for how many cycles?</a:t>
+            </a:r>
+            <a:endParaRPr lang="en-US" sz="1800" dirty="0"/>
+          </a:p>
+        </p:txBody>
+      </p:sp>
+      <p:sp>
+        <p:nvSpPr>
+          <p:cNvPr id="6" name="Shape 6"/>
+          <p:cNvSpPr/>
+          <p:nvPr/>
+        </p:nvSpPr>
+        <p:spPr>
+          <a:xfrm>
+            <a:off x="1097280" y="5029200"/>
+            <a:ext cx="9692640" cy="640080"/>
+          </a:xfrm>
+          <a:prstGeom prst="roundRect">
+            <a:avLst>
+              <a:gd name="adj" fmla="val 22000"/>
+            </a:avLst>
+          </a:prstGeom>
+          <a:solidFill>
+            <a:srgbClr val="EEE6F3"/>
+          </a:solidFill>
+          <a:ln>
+            <a:noFill/>
+          </a:ln>
+        </p:spPr>
+        <p:txBody>
+          <a:bodyPr wrap="square" lIns="54864" tIns="27432" rIns="54864" bIns="27432" anchor="ctr" rtlCol="0">
+            <a:noAutofit/>
+          </a:bodyPr>
+          <a:lstStyle/>
+          <a:p>
+            <a:pPr algn="ctr"/>
+            <a:r>
+              <a:rPr lang="en-US" sz="1600" dirty="0">
+                <a:solidFill>
+                  <a:srgbClr val="262626"/>
+                </a:solidFill>
+              </a:rPr>
+              <a:t xml:space="preserve">A transfer happens on the first cycle where </a:t>
+            </a:r>
+            <a:r>
+              <a:rPr lang="en-US" sz="1600" b="1" dirty="0">
+                <a:solidFill>
+                  <a:srgbClr val="57068C"/>
+                </a:solidFill>
+              </a:rPr>
+              <a:t>VALID</a:t>
+            </a:r>
+            <a:r>
+              <a:rPr lang="en-US" sz="1600" dirty="0">
+                <a:solidFill>
+                  <a:srgbClr val="262626"/>
+                </a:solidFill>
+              </a:rPr>
+              <a:t xml:space="preserve"> and </a:t>
+            </a:r>
+            <a:r>
+              <a:rPr lang="en-US" sz="1600" b="1" dirty="0">
+                <a:solidFill>
+                  <a:srgbClr val="57068C"/>
+                </a:solidFill>
+              </a:rPr>
+              <a:t>READY</a:t>
+            </a:r>
+            <a:r>
+              <a:rPr lang="en-US" sz="1600" dirty="0">
+                <a:solidFill>
+                  <a:srgbClr val="262626"/>
+                </a:solidFill>
+              </a:rPr>
+              <a:t xml:space="preserve"> are both high.</a:t>
+            </a:r>
+            <a:endParaRPr lang="en-US" sz="1600" dirty="0"/>
+          </a:p>
+        </p:txBody>
+      </p:sp>
+      <p:sp>
+        <p:nvSpPr>
+          <p:cNvPr id="7" name="TextBox 7"/>
+          <p:cNvSpPr txBox="1"/>
+          <p:nvPr/>
+        </p:nvSpPr>
+        <p:spPr>
+          <a:xfrm>
+            <a:off x="1097280" y="5669280"/>
+            <a:ext cx="8229600" cy="292608"/>
+          </a:xfrm>
+          <a:prstGeom prst="rect">
+            <a:avLst/>
+          </a:prstGeom>
+          <a:noFill/>
+        </p:spPr>
+        <p:txBody>
+          <a:bodyPr wrap="square" lIns="0" tIns="0" rIns="0" bIns="0" anchor="t" rtlCol="0">
+            <a:noAutofit/>
+          </a:bodyPr>
+          <a:lstStyle/>
+          <a:p>
+            <a:r>
+              <a:rPr lang="en-US" sz="1200" dirty="0">
+                <a:solidFill>
+                  <a:srgbClr val="6E6E6E"/>
+                </a:solidFill>
+              </a:rPr>
+              <a:t>Also in the LLM grader: Unit 4 › Reading a write timing diagram</a:t>
             </a:r>
             <a:endParaRPr lang="en-US" sz="1200" dirty="0"/>
           </a:p>

</xml_diff>